<commit_message>
docs: cambio de integrante, auditoría del 25-sep y pitch de 1 minuto
Bryan Martínez Villamarín reemplaza a Daniel Celis en Markdown, PPTX, DOCX y PDF.

Co-Authored-By: Claude Opus 5.5 <noreply@anthropic.com>
</commit_message>
<xml_diff>
--- a/entregables/presentacion/Cali_Activa_Presentacion.pptx
+++ b/entregables/presentacion/Cali_Activa_Presentacion.pptx
@@ -595,7 +595,7 @@
           <a:p/>
           <a:p>
             <a:r>
-              <a:t>El valor es hacer explícitas las decisiones: por qué un lugar se revisa, cuánto se propone ocupar y qué falta resolver. El siguiente paso técnico es completar mediciones y servicios. Cali Activa propone y documenta; la autoridad decide. El equipo es William Ortiz, Herlin Echeverry, Pablo Arango y Daniel Celis.</a:t>
+              <a:t>El valor es hacer explícitas las decisiones: por qué un lugar se revisa, cuánto se propone ocupar y qué falta resolver. El siguiente paso técnico es completar mediciones y servicios. Cali Activa propone y documenta; la autoridad decide. El equipo es William Ortiz, Herlin Echeverry, Pablo Arango y Bryan Martínez Villamarín.</a:t>
             </a:r>
           </a:p>
         </p:txBody>
@@ -5986,7 +5986,7 @@
               </a:defRPr>
             </a:pPr>
             <a:r>
-              <a:t>Equipo: William Ortiz · Herlin Echeverry · Pablo Arango · Daniel Celis</a:t>
+              <a:t>Equipo: William Ortiz · Herlin Echeverry · Pablo Arango · Bryan Martínez Villamarín</a:t>
             </a:r>
           </a:p>
         </p:txBody>

</xml_diff>